<commit_message>
Add 4NF and 5NF slides to Advanced Normalization Concepts PPTX
Agent-Logs-Url: https://github.com/rbpelegrinojr/topic/sessions/2df9a606-7fd5-431a-8072-a252884e9ed1

Co-authored-by: rbpelegrinojr <272832130+rbpelegrinojr@users.noreply.github.com>
</commit_message>
<xml_diff>
--- a/Advand_Normalization_Concepts (1).pptx
+++ b/Advand_Normalization_Concepts (1).pptx
@@ -13,6 +13,8 @@
     <p:sldId id="259" r:id="rId4"/>
     <p:sldId id="260" r:id="rId5"/>
     <p:sldId id="261" r:id="rId6"/>
+    <p:sldId id="266" r:id="rId16"/>
+    <p:sldId id="267" r:id="rId17"/>
     <p:sldId id="262" r:id="rId7"/>
     <p:sldId id="263" r:id="rId8"/>
     <p:sldId id="264" r:id="rId9"/>
@@ -9940,6 +9942,2066 @@
                 </a:solidFill>
               </a:rPr>
               <a:t>April 2026</a:t>
+            </a:r>
+          </a:p>
+        </p:txBody>
+      </p:sp>
+    </p:spTree>
+  </p:cSld>
+  <p:clrMapOvr>
+    <a:masterClrMapping/>
+  </p:clrMapOvr>
+</p:sld>
+</file>
+
+<file path=ppt/slides/slide10.xml><?xml version="1.0" encoding="utf-8"?>
+<p:sld xmlns:a="http://schemas.openxmlformats.org/drawingml/2006/main" xmlns:p="http://schemas.openxmlformats.org/presentationml/2006/main" xmlns:r="http://schemas.openxmlformats.org/officeDocument/2006/relationships">
+  <p:cSld>
+    <p:spTree>
+      <p:nvGrpSpPr>
+        <p:cNvPr id="1" name=""/>
+        <p:cNvGrpSpPr/>
+        <p:nvPr/>
+      </p:nvGrpSpPr>
+      <p:grpSpPr>
+        <a:xfrm>
+          <a:off x="0" y="0"/>
+          <a:ext cx="0" cy="0"/>
+          <a:chOff x="0" y="0"/>
+          <a:chExt cx="0" cy="0"/>
+        </a:xfrm>
+      </p:grpSpPr>
+      <p:sp>
+        <p:nvSpPr>
+          <p:cNvPr id="2" name="Rectangle 1"/>
+          <p:cNvSpPr/>
+          <p:nvPr/>
+        </p:nvSpPr>
+        <p:spPr>
+          <a:xfrm>
+            <a:off x="0" y="0"/>
+            <a:ext cx="12188952" cy="6858000"/>
+          </a:xfrm>
+          <a:prstGeom prst="rect">
+            <a:avLst/>
+          </a:prstGeom>
+          <a:solidFill>
+            <a:srgbClr val="0D1B2A"/>
+          </a:solidFill>
+          <a:ln>
+            <a:noFill/>
+          </a:ln>
+        </p:spPr>
+        <p:style>
+          <a:lnRef idx="1">
+            <a:schemeClr val="accent1"/>
+          </a:lnRef>
+          <a:fillRef idx="3">
+            <a:schemeClr val="accent1"/>
+          </a:fillRef>
+          <a:effectRef idx="2">
+            <a:schemeClr val="accent1"/>
+          </a:effectRef>
+          <a:fontRef idx="minor">
+            <a:schemeClr val="lt1"/>
+          </a:fontRef>
+        </p:style>
+        <p:txBody>
+          <a:bodyPr rtlCol="0" anchor="ctr"/>
+          <a:lstStyle/>
+          <a:p>
+            <a:pPr algn="ctr"/>
+            <a:endParaRPr/>
+          </a:p>
+        </p:txBody>
+      </p:sp>
+      <p:sp>
+        <p:nvSpPr>
+          <p:cNvPr id="3" name="Rectangle 2"/>
+          <p:cNvSpPr/>
+          <p:nvPr/>
+        </p:nvSpPr>
+        <p:spPr>
+          <a:xfrm>
+            <a:off x="0" y="0"/>
+            <a:ext cx="12188952" cy="109728"/>
+          </a:xfrm>
+          <a:prstGeom prst="rect">
+            <a:avLst/>
+          </a:prstGeom>
+          <a:solidFill>
+            <a:srgbClr val="268BD2"/>
+          </a:solidFill>
+          <a:ln>
+            <a:noFill/>
+          </a:ln>
+        </p:spPr>
+        <p:style>
+          <a:lnRef idx="1">
+            <a:schemeClr val="accent1"/>
+          </a:lnRef>
+          <a:fillRef idx="3">
+            <a:schemeClr val="accent1"/>
+          </a:fillRef>
+          <a:effectRef idx="2">
+            <a:schemeClr val="accent1"/>
+          </a:effectRef>
+          <a:fontRef idx="minor">
+            <a:schemeClr val="lt1"/>
+          </a:fontRef>
+        </p:style>
+        <p:txBody>
+          <a:bodyPr rtlCol="0" anchor="ctr"/>
+          <a:lstStyle/>
+          <a:p>
+            <a:pPr algn="ctr"/>
+            <a:endParaRPr/>
+          </a:p>
+        </p:txBody>
+      </p:sp>
+      <p:sp>
+        <p:nvSpPr>
+          <p:cNvPr id="4" name="Rectangle 3"/>
+          <p:cNvSpPr/>
+          <p:nvPr/>
+        </p:nvSpPr>
+        <p:spPr>
+          <a:xfrm>
+            <a:off x="0" y="6629400"/>
+            <a:ext cx="12188952" cy="228600"/>
+          </a:xfrm>
+          <a:prstGeom prst="rect">
+            <a:avLst/>
+          </a:prstGeom>
+          <a:solidFill>
+            <a:srgbClr val="1B488B"/>
+          </a:solidFill>
+          <a:ln>
+            <a:noFill/>
+          </a:ln>
+        </p:spPr>
+        <p:style>
+          <a:lnRef idx="1">
+            <a:schemeClr val="accent1"/>
+          </a:lnRef>
+          <a:fillRef idx="3">
+            <a:schemeClr val="accent1"/>
+          </a:fillRef>
+          <a:effectRef idx="2">
+            <a:schemeClr val="accent1"/>
+          </a:effectRef>
+          <a:fontRef idx="minor">
+            <a:schemeClr val="lt1"/>
+          </a:fontRef>
+        </p:style>
+        <p:txBody>
+          <a:bodyPr rtlCol="0" anchor="ctr"/>
+          <a:lstStyle/>
+          <a:p>
+            <a:pPr algn="ctr"/>
+            <a:endParaRPr/>
+          </a:p>
+        </p:txBody>
+      </p:sp>
+      <p:sp>
+        <p:nvSpPr>
+          <p:cNvPr id="5" name="TextBox 4"/>
+          <p:cNvSpPr txBox="1"/>
+          <p:nvPr/>
+        </p:nvSpPr>
+        <p:spPr>
+          <a:xfrm>
+            <a:off x="9601200" y="6601968"/>
+            <a:ext cx="2468880" cy="256032"/>
+          </a:xfrm>
+          <a:prstGeom prst="rect">
+            <a:avLst/>
+          </a:prstGeom>
+          <a:noFill/>
+        </p:spPr>
+        <p:txBody>
+          <a:bodyPr wrap="square">
+            <a:spAutoFit/>
+          </a:bodyPr>
+          <a:lstStyle/>
+          <a:p>
+            <a:pPr algn="r"/>
+            <a:r>
+              <a:rPr sz="900" b="0" i="0">
+                <a:solidFill>
+                  <a:srgbClr val="ECEFF4"/>
+                </a:solidFill>
+              </a:rPr>
+              <a:t>B. Normal Forms</a:t>
+            </a:r>
+          </a:p>
+        </p:txBody>
+      </p:sp>
+      <p:sp>
+        <p:nvSpPr>
+          <p:cNvPr id="6" name="Rectangle 5"/>
+          <p:cNvSpPr/>
+          <p:nvPr/>
+        </p:nvSpPr>
+        <p:spPr>
+          <a:xfrm>
+            <a:off x="365760" y="164592"/>
+            <a:ext cx="11457432" cy="868680"/>
+          </a:xfrm>
+          <a:prstGeom prst="rect">
+            <a:avLst/>
+          </a:prstGeom>
+          <a:solidFill>
+            <a:srgbClr val="1B488B"/>
+          </a:solidFill>
+          <a:ln>
+            <a:noFill/>
+          </a:ln>
+        </p:spPr>
+        <p:style>
+          <a:lnRef idx="1">
+            <a:schemeClr val="accent1"/>
+          </a:lnRef>
+          <a:fillRef idx="3">
+            <a:schemeClr val="accent1"/>
+          </a:fillRef>
+          <a:effectRef idx="2">
+            <a:schemeClr val="accent1"/>
+          </a:effectRef>
+          <a:fontRef idx="minor">
+            <a:schemeClr val="lt1"/>
+          </a:fontRef>
+        </p:style>
+        <p:txBody>
+          <a:bodyPr rtlCol="0" anchor="ctr"/>
+          <a:lstStyle/>
+          <a:p>
+            <a:pPr algn="ctr"/>
+            <a:endParaRPr/>
+          </a:p>
+        </p:txBody>
+      </p:sp>
+      <p:sp>
+        <p:nvSpPr>
+          <p:cNvPr id="7" name="TextBox 6"/>
+          <p:cNvSpPr txBox="1"/>
+          <p:nvPr/>
+        </p:nvSpPr>
+        <p:spPr>
+          <a:xfrm>
+            <a:off x="502920" y="182880"/>
+            <a:ext cx="11155680" cy="822960"/>
+          </a:xfrm>
+          <a:prstGeom prst="rect">
+            <a:avLst/>
+          </a:prstGeom>
+          <a:noFill/>
+        </p:spPr>
+        <p:txBody>
+          <a:bodyPr wrap="square">
+            <a:spAutoFit/>
+          </a:bodyPr>
+          <a:lstStyle/>
+          <a:p>
+            <a:pPr algn="l"/>
+            <a:r>
+              <a:rPr sz="2800" b="1" i="0">
+                <a:solidFill>
+                  <a:srgbClr val="FFFFFF"/>
+                </a:solidFill>
+              </a:rPr>
+              <a:t>Fourth Normal Form (4NF) — Eliminating Multi-Valued Dependencies</a:t>
+            </a:r>
+          </a:p>
+        </p:txBody>
+      </p:sp>
+      <p:sp>
+        <p:nvSpPr>
+          <p:cNvPr id="8" name="Rectangle 7"/>
+          <p:cNvSpPr/>
+          <p:nvPr/>
+        </p:nvSpPr>
+        <p:spPr>
+          <a:xfrm>
+            <a:off x="365760" y="1207008"/>
+            <a:ext cx="11430000" cy="768096"/>
+          </a:xfrm>
+          <a:prstGeom prst="rect">
+            <a:avLst/>
+          </a:prstGeom>
+          <a:solidFill>
+            <a:srgbClr val="1B488B"/>
+          </a:solidFill>
+          <a:ln>
+            <a:noFill/>
+          </a:ln>
+        </p:spPr>
+        <p:style>
+          <a:lnRef idx="1">
+            <a:schemeClr val="accent1"/>
+          </a:lnRef>
+          <a:fillRef idx="3">
+            <a:schemeClr val="accent1"/>
+          </a:fillRef>
+          <a:effectRef idx="2">
+            <a:schemeClr val="accent1"/>
+          </a:effectRef>
+          <a:fontRef idx="minor">
+            <a:schemeClr val="lt1"/>
+          </a:fontRef>
+        </p:style>
+        <p:txBody>
+          <a:bodyPr rtlCol="0" anchor="ctr"/>
+          <a:lstStyle/>
+          <a:p>
+            <a:pPr algn="ctr"/>
+            <a:endParaRPr/>
+          </a:p>
+        </p:txBody>
+      </p:sp>
+      <p:sp>
+        <p:nvSpPr>
+          <p:cNvPr id="9" name="TextBox 8"/>
+          <p:cNvSpPr txBox="1"/>
+          <p:nvPr/>
+        </p:nvSpPr>
+        <p:spPr>
+          <a:xfrm>
+            <a:off x="502920" y="1225296"/>
+            <a:ext cx="2743200" cy="292608"/>
+          </a:xfrm>
+          <a:prstGeom prst="rect">
+            <a:avLst/>
+          </a:prstGeom>
+          <a:noFill/>
+        </p:spPr>
+        <p:txBody>
+          <a:bodyPr wrap="square">
+            <a:spAutoFit/>
+          </a:bodyPr>
+          <a:lstStyle/>
+          <a:p>
+            <a:pPr algn="l"/>
+            <a:r>
+              <a:rPr sz="1400" b="1" i="0">
+                <a:solidFill>
+                  <a:srgbClr val="FFD166"/>
+                </a:solidFill>
+              </a:rPr>
+              <a:t>Definition</a:t>
+            </a:r>
+          </a:p>
+        </p:txBody>
+      </p:sp>
+      <p:sp>
+        <p:nvSpPr>
+          <p:cNvPr id="10" name="TextBox 9"/>
+          <p:cNvSpPr txBox="1"/>
+          <p:nvPr/>
+        </p:nvSpPr>
+        <p:spPr>
+          <a:xfrm>
+            <a:off x="502920" y="1481328"/>
+            <a:ext cx="11155680" cy="365760"/>
+          </a:xfrm>
+          <a:prstGeom prst="rect">
+            <a:avLst/>
+          </a:prstGeom>
+          <a:noFill/>
+        </p:spPr>
+        <p:txBody>
+          <a:bodyPr wrap="square">
+            <a:spAutoFit/>
+          </a:bodyPr>
+          <a:lstStyle/>
+          <a:p>
+            <a:pPr algn="l"/>
+            <a:r>
+              <a:rPr sz="1300" b="0" i="0">
+                <a:solidFill>
+                  <a:srgbClr val="FFFFFF"/>
+                </a:solidFill>
+              </a:rPr>
+              <a:t>A table is in 4NF if: (1) It is already in BCNF, AND (2) It contains no non-trivial multi-valued dependencies (MVDs) — i.e., no attribute independently determines a SET of values for another attribute.</a:t>
+            </a:r>
+          </a:p>
+        </p:txBody>
+      </p:sp>
+      <p:sp>
+        <p:nvSpPr>
+          <p:cNvPr id="11" name="TextBox 10"/>
+          <p:cNvSpPr txBox="1"/>
+          <p:nvPr/>
+        </p:nvSpPr>
+        <p:spPr>
+          <a:xfrm>
+            <a:off x="365760" y="1938528"/>
+            <a:ext cx="11430000" cy="274320"/>
+          </a:xfrm>
+          <a:prstGeom prst="rect">
+            <a:avLst/>
+          </a:prstGeom>
+          <a:noFill/>
+        </p:spPr>
+        <p:txBody>
+          <a:bodyPr wrap="square">
+            <a:spAutoFit/>
+          </a:bodyPr>
+          <a:lstStyle/>
+          <a:p>
+            <a:pPr algn="l"/>
+            <a:r>
+              <a:rPr sz="1300" b="0" i="0">
+                <a:solidFill>
+                  <a:srgbClr val="FFD166"/>
+                </a:solidFill>
+              </a:rPr>
+              <a:t>⚠  Multi-Valued Dependency (MVD): A →→ B means each value of A determines a SET of B values, independently of all other attributes in the table.</a:t>
+            </a:r>
+          </a:p>
+        </p:txBody>
+      </p:sp>
+      <p:sp>
+        <p:nvSpPr>
+          <p:cNvPr id="12" name="TextBox 11"/>
+          <p:cNvSpPr txBox="1"/>
+          <p:nvPr/>
+        </p:nvSpPr>
+        <p:spPr>
+          <a:xfrm>
+            <a:off x="365760" y="2304288"/>
+            <a:ext cx="5486400" cy="274320"/>
+          </a:xfrm>
+          <a:prstGeom prst="rect">
+            <a:avLst/>
+          </a:prstGeom>
+          <a:noFill/>
+        </p:spPr>
+        <p:txBody>
+          <a:bodyPr wrap="square">
+            <a:spAutoFit/>
+          </a:bodyPr>
+          <a:lstStyle/>
+          <a:p>
+            <a:pPr algn="l"/>
+            <a:r>
+              <a:rPr sz="1200" b="1" i="0" dirty="0">
+                <a:solidFill>
+                  <a:srgbClr val="E74C3C"/>
+                </a:solidFill>
+              </a:rPr>
+              <a:t>❌  Violation Example (PK: CourseID):</a:t>
+            </a:r>
+          </a:p>
+        </p:txBody>
+      </p:sp>
+      <p:sp>
+        <p:nvSpPr>
+          <p:cNvPr id="13" name="Rectangle 12"/>
+          <p:cNvSpPr/>
+          <p:nvPr/>
+        </p:nvSpPr>
+        <p:spPr>
+          <a:xfrm>
+            <a:off x="365760" y="2596896"/>
+            <a:ext cx="11430000" cy="658368"/>
+          </a:xfrm>
+          <a:prstGeom prst="rect">
+            <a:avLst/>
+          </a:prstGeom>
+          <a:solidFill>
+            <a:srgbClr val="102540"/>
+          </a:solidFill>
+          <a:ln>
+            <a:noFill/>
+          </a:ln>
+        </p:spPr>
+        <p:style>
+          <a:lnRef idx="1">
+            <a:schemeClr val="accent1"/>
+          </a:lnRef>
+          <a:fillRef idx="3">
+            <a:schemeClr val="accent1"/>
+          </a:fillRef>
+          <a:effectRef idx="2">
+            <a:schemeClr val="accent1"/>
+          </a:effectRef>
+          <a:fontRef idx="minor">
+            <a:schemeClr val="lt1"/>
+          </a:fontRef>
+        </p:style>
+        <p:txBody>
+          <a:bodyPr rtlCol="0" anchor="ctr"/>
+          <a:lstStyle/>
+          <a:p>
+            <a:pPr algn="ctr"/>
+            <a:endParaRPr/>
+          </a:p>
+        </p:txBody>
+      </p:sp>
+      <p:sp>
+        <p:nvSpPr>
+          <p:cNvPr id="14" name="TextBox 13"/>
+          <p:cNvSpPr txBox="1"/>
+          <p:nvPr/>
+        </p:nvSpPr>
+        <p:spPr>
+          <a:xfrm>
+            <a:off x="502920" y="2615184"/>
+            <a:ext cx="11155680" cy="621792"/>
+          </a:xfrm>
+          <a:prstGeom prst="rect">
+            <a:avLst/>
+          </a:prstGeom>
+          <a:noFill/>
+        </p:spPr>
+        <p:txBody>
+          <a:bodyPr wrap="square">
+            <a:spAutoFit/>
+          </a:bodyPr>
+          <a:lstStyle/>
+          <a:p>
+            <a:pPr algn="l"/>
+            <a:r>
+              <a:rPr sz="1100" b="0" i="0">
+                <a:solidFill>
+                  <a:srgbClr val="ECEFF4"/>
+                </a:solidFill>
+              </a:rPr>
+              <a:t>  CourseID  |  Teacher    |  Textbook</a:t>
+            </a:r>
+          </a:p>
+          <a:p>
+            <a:pPr algn="l"/>
+            <a:r>
+              <a:rPr sz="1100" b="0" i="0">
+                <a:solidFill>
+                  <a:srgbClr val="ECEFF4"/>
+                </a:solidFill>
+              </a:rPr>
+              <a:t>  ─────────────────────────────────────────────────</a:t>
+            </a:r>
+          </a:p>
+          <a:p>
+            <a:pPr algn="l"/>
+            <a:r>
+              <a:rPr sz="1100" b="0" i="0">
+                <a:solidFill>
+                  <a:srgbClr val="ECEFF4"/>
+                </a:solidFill>
+              </a:rPr>
+              <a:t>  CS101     |  Alice      |  DB Systems</a:t>
+            </a:r>
+          </a:p>
+          <a:p>
+            <a:pPr algn="l"/>
+            <a:r>
+              <a:rPr sz="1100" b="0" i="0">
+                <a:solidFill>
+                  <a:srgbClr val="ECEFF4"/>
+                </a:solidFill>
+              </a:rPr>
+              <a:t>  CS101     |  Alice      |  SQL Guide</a:t>
+            </a:r>
+          </a:p>
+          <a:p>
+            <a:pPr algn="l"/>
+            <a:r>
+              <a:rPr sz="1100" b="0" i="0">
+                <a:solidFill>
+                  <a:srgbClr val="ECEFF4"/>
+                </a:solidFill>
+              </a:rPr>
+              <a:t>  CS101     |  Bob        |  DB Systems</a:t>
+            </a:r>
+          </a:p>
+          <a:p>
+            <a:pPr algn="l"/>
+            <a:r>
+              <a:rPr sz="1100" b="0" i="0">
+                <a:solidFill>
+                  <a:srgbClr val="ECEFF4"/>
+                </a:solidFill>
+              </a:rPr>
+              <a:t>  CS101     |  Bob        |  SQL Guide</a:t>
+            </a:r>
+          </a:p>
+        </p:txBody>
+      </p:sp>
+      <p:sp>
+        <p:nvSpPr>
+          <p:cNvPr id="15" name="TextBox 14"/>
+          <p:cNvSpPr txBox="1"/>
+          <p:nvPr/>
+        </p:nvSpPr>
+        <p:spPr>
+          <a:xfrm>
+            <a:off x="365760" y="3328416"/>
+            <a:ext cx="7772400" cy="877824"/>
+          </a:xfrm>
+          <a:prstGeom prst="rect">
+            <a:avLst/>
+          </a:prstGeom>
+          <a:noFill/>
+        </p:spPr>
+        <p:txBody>
+          <a:bodyPr wrap="square">
+            <a:spAutoFit/>
+          </a:bodyPr>
+          <a:lstStyle/>
+          <a:p>
+            <a:pPr algn="l"/>
+            <a:r>
+              <a:rPr sz="1200" b="0" dirty="0">
+                <a:solidFill>
+                  <a:srgbClr val="FFFFFF"/>
+                </a:solidFill>
+              </a:rPr>
+              <a:t>  CourseID →→ Teacher        ⚠  independent MVD</a:t>
+            </a:r>
+          </a:p>
+          <a:p>
+            <a:pPr algn="l"/>
+            <a:r>
+              <a:rPr sz="1200" b="0" dirty="0">
+                <a:solidFill>
+                  <a:srgbClr val="FFFFFF"/>
+                </a:solidFill>
+              </a:rPr>
+              <a:t>  CourseID →→ Textbook       ⚠  independent MVD</a:t>
+            </a:r>
+          </a:p>
+          <a:p>
+            <a:pPr algn="l"/>
+            <a:r>
+              <a:rPr sz="1200" b="0" dirty="0">
+                <a:solidFill>
+                  <a:srgbClr val="FFD166"/>
+                </a:solidFill>
+              </a:rPr>
+              <a:t>  Two independent MVDs in one table → violates 4NF!</a:t>
+            </a:r>
+          </a:p>
+        </p:txBody>
+      </p:sp>
+      <p:sp>
+        <p:nvSpPr>
+          <p:cNvPr id="16" name="Rectangle 15"/>
+          <p:cNvSpPr/>
+          <p:nvPr/>
+        </p:nvSpPr>
+        <p:spPr>
+          <a:xfrm>
+            <a:off x="8275320" y="3328416"/>
+            <a:ext cx="3474720" cy="877824"/>
+          </a:xfrm>
+          <a:prstGeom prst="rect">
+            <a:avLst/>
+          </a:prstGeom>
+          <a:solidFill>
+            <a:srgbClr val="401010"/>
+          </a:solidFill>
+          <a:ln>
+            <a:noFill/>
+          </a:ln>
+        </p:spPr>
+        <p:style>
+          <a:lnRef idx="1">
+            <a:schemeClr val="accent1"/>
+          </a:lnRef>
+          <a:fillRef idx="3">
+            <a:schemeClr val="accent1"/>
+          </a:fillRef>
+          <a:effectRef idx="2">
+            <a:schemeClr val="accent1"/>
+          </a:effectRef>
+          <a:fontRef idx="minor">
+            <a:schemeClr val="lt1"/>
+          </a:fontRef>
+        </p:style>
+        <p:txBody>
+          <a:bodyPr rtlCol="0" anchor="ctr"/>
+          <a:lstStyle/>
+          <a:p>
+            <a:pPr algn="ctr"/>
+            <a:endParaRPr/>
+          </a:p>
+        </p:txBody>
+      </p:sp>
+      <p:sp>
+        <p:nvSpPr>
+          <p:cNvPr id="17" name="TextBox 16"/>
+          <p:cNvSpPr txBox="1"/>
+          <p:nvPr/>
+        </p:nvSpPr>
+        <p:spPr>
+          <a:xfrm>
+            <a:off x="8366760" y="3346704"/>
+            <a:ext cx="3291840" cy="256032"/>
+          </a:xfrm>
+          <a:prstGeom prst="rect">
+            <a:avLst/>
+          </a:prstGeom>
+          <a:noFill/>
+        </p:spPr>
+        <p:txBody>
+          <a:bodyPr wrap="square">
+            <a:spAutoFit/>
+          </a:bodyPr>
+          <a:lstStyle/>
+          <a:p>
+            <a:pPr algn="l"/>
+            <a:r>
+              <a:rPr sz="1200" b="1" i="0">
+                <a:solidFill>
+                  <a:srgbClr val="FFD166"/>
+                </a:solidFill>
+              </a:rPr>
+              <a:t>Why It Matters:</a:t>
+            </a:r>
+          </a:p>
+        </p:txBody>
+      </p:sp>
+      <p:sp>
+        <p:nvSpPr>
+          <p:cNvPr id="18" name="TextBox 17"/>
+          <p:cNvSpPr txBox="1"/>
+          <p:nvPr/>
+        </p:nvSpPr>
+        <p:spPr>
+          <a:xfrm>
+            <a:off x="8366760" y="3621024"/>
+            <a:ext cx="3291840" cy="548640"/>
+          </a:xfrm>
+          <a:prstGeom prst="rect">
+            <a:avLst/>
+          </a:prstGeom>
+          <a:noFill/>
+        </p:spPr>
+        <p:txBody>
+          <a:bodyPr wrap="square">
+            <a:spAutoFit/>
+          </a:bodyPr>
+          <a:lstStyle/>
+          <a:p>
+            <a:pPr algn="l"/>
+            <a:r>
+              <a:rPr sz="1100" b="0">
+                <a:solidFill>
+                  <a:srgbClr val="FFFFFF"/>
+                </a:solidFill>
+              </a:rPr>
+              <a:t>  ⚠  Update Anomaly</a:t>
+            </a:r>
+          </a:p>
+          <a:p>
+            <a:pPr algn="l"/>
+            <a:r>
+              <a:rPr sz="1100" b="0">
+                <a:solidFill>
+                  <a:srgbClr val="FFFFFF"/>
+                </a:solidFill>
+              </a:rPr>
+              <a:t>  ⚠  Insertion Anomaly</a:t>
+            </a:r>
+          </a:p>
+          <a:p>
+            <a:pPr algn="l"/>
+            <a:r>
+              <a:rPr sz="1100" b="0">
+                <a:solidFill>
+                  <a:srgbClr val="FFFFFF"/>
+                </a:solidFill>
+              </a:rPr>
+              <a:t>  ⚠  Deletion Anomaly</a:t>
+            </a:r>
+          </a:p>
+        </p:txBody>
+      </p:sp>
+      <p:sp>
+        <p:nvSpPr>
+          <p:cNvPr id="19" name="TextBox 18"/>
+          <p:cNvSpPr txBox="1"/>
+          <p:nvPr/>
+        </p:nvSpPr>
+        <p:spPr>
+          <a:xfrm>
+            <a:off x="365760" y="4315968"/>
+            <a:ext cx="7315200" cy="274320"/>
+          </a:xfrm>
+          <a:prstGeom prst="rect">
+            <a:avLst/>
+          </a:prstGeom>
+          <a:noFill/>
+        </p:spPr>
+        <p:txBody>
+          <a:bodyPr wrap="square">
+            <a:spAutoFit/>
+          </a:bodyPr>
+          <a:lstStyle/>
+          <a:p>
+            <a:pPr algn="l"/>
+            <a:r>
+              <a:rPr sz="1200" b="1" i="0">
+                <a:solidFill>
+                  <a:srgbClr val="2ECC71"/>
+                </a:solidFill>
+              </a:rPr>
+              <a:t>✅  Solution — Decompose into 2 tables (one MVD per table):</a:t>
+            </a:r>
+          </a:p>
+        </p:txBody>
+      </p:sp>
+      <p:sp>
+        <p:nvSpPr>
+          <p:cNvPr id="20" name="Rectangle 19"/>
+          <p:cNvSpPr/>
+          <p:nvPr/>
+        </p:nvSpPr>
+        <p:spPr>
+          <a:xfrm>
+            <a:off x="365760" y="4626864"/>
+            <a:ext cx="5303520" cy="585216"/>
+          </a:xfrm>
+          <a:prstGeom prst="rect">
+            <a:avLst/>
+          </a:prstGeom>
+          <a:solidFill>
+            <a:srgbClr val="0D301A"/>
+          </a:solidFill>
+          <a:ln>
+            <a:noFill/>
+          </a:ln>
+        </p:spPr>
+        <p:style>
+          <a:lnRef idx="1">
+            <a:schemeClr val="accent1"/>
+          </a:lnRef>
+          <a:fillRef idx="3">
+            <a:schemeClr val="accent1"/>
+          </a:fillRef>
+          <a:effectRef idx="2">
+            <a:schemeClr val="accent1"/>
+          </a:effectRef>
+          <a:fontRef idx="minor">
+            <a:schemeClr val="lt1"/>
+          </a:fontRef>
+        </p:style>
+        <p:txBody>
+          <a:bodyPr rtlCol="0" anchor="ctr"/>
+          <a:lstStyle/>
+          <a:p>
+            <a:pPr algn="ctr"/>
+            <a:endParaRPr/>
+          </a:p>
+        </p:txBody>
+      </p:sp>
+      <p:sp>
+        <p:nvSpPr>
+          <p:cNvPr id="21" name="TextBox 20"/>
+          <p:cNvSpPr txBox="1"/>
+          <p:nvPr/>
+        </p:nvSpPr>
+        <p:spPr>
+          <a:xfrm>
+            <a:off x="502920" y="4645152"/>
+            <a:ext cx="5120640" cy="237744"/>
+          </a:xfrm>
+          <a:prstGeom prst="rect">
+            <a:avLst/>
+          </a:prstGeom>
+          <a:noFill/>
+        </p:spPr>
+        <p:txBody>
+          <a:bodyPr wrap="square">
+            <a:spAutoFit/>
+          </a:bodyPr>
+          <a:lstStyle/>
+          <a:p>
+            <a:pPr algn="l"/>
+            <a:r>
+              <a:rPr sz="1200" b="1" i="0">
+                <a:solidFill>
+                  <a:srgbClr val="FFD166"/>
+                </a:solidFill>
+              </a:rPr>
+              <a:t>Course_Teacher:</a:t>
+            </a:r>
+          </a:p>
+        </p:txBody>
+      </p:sp>
+      <p:sp>
+        <p:nvSpPr>
+          <p:cNvPr id="22" name="TextBox 21"/>
+          <p:cNvSpPr txBox="1"/>
+          <p:nvPr/>
+        </p:nvSpPr>
+        <p:spPr>
+          <a:xfrm>
+            <a:off x="502920" y="4882896"/>
+            <a:ext cx="5120640" cy="292608"/>
+          </a:xfrm>
+          <a:prstGeom prst="rect">
+            <a:avLst/>
+          </a:prstGeom>
+          <a:noFill/>
+        </p:spPr>
+        <p:txBody>
+          <a:bodyPr wrap="square">
+            <a:spAutoFit/>
+          </a:bodyPr>
+          <a:lstStyle/>
+          <a:p>
+            <a:pPr algn="l"/>
+            <a:r>
+              <a:rPr sz="1100" b="0" i="0">
+                <a:solidFill>
+                  <a:srgbClr val="ECEFF4"/>
+                </a:solidFill>
+              </a:rPr>
+              <a:t>CourseID  |  Teacher</a:t>
+            </a:r>
+          </a:p>
+        </p:txBody>
+      </p:sp>
+      <p:sp>
+        <p:nvSpPr>
+          <p:cNvPr id="23" name="Rectangle 22"/>
+          <p:cNvSpPr/>
+          <p:nvPr/>
+        </p:nvSpPr>
+        <p:spPr>
+          <a:xfrm>
+            <a:off x="6492240" y="4626864"/>
+            <a:ext cx="5303520" cy="585216"/>
+          </a:xfrm>
+          <a:prstGeom prst="rect">
+            <a:avLst/>
+          </a:prstGeom>
+          <a:solidFill>
+            <a:srgbClr val="0D301A"/>
+          </a:solidFill>
+          <a:ln>
+            <a:noFill/>
+          </a:ln>
+        </p:spPr>
+        <p:style>
+          <a:lnRef idx="1">
+            <a:schemeClr val="accent1"/>
+          </a:lnRef>
+          <a:fillRef idx="3">
+            <a:schemeClr val="accent1"/>
+          </a:fillRef>
+          <a:effectRef idx="2">
+            <a:schemeClr val="accent1"/>
+          </a:effectRef>
+          <a:fontRef idx="minor">
+            <a:schemeClr val="lt1"/>
+          </a:fontRef>
+        </p:style>
+        <p:txBody>
+          <a:bodyPr rtlCol="0" anchor="ctr"/>
+          <a:lstStyle/>
+          <a:p>
+            <a:pPr algn="ctr"/>
+            <a:endParaRPr/>
+          </a:p>
+        </p:txBody>
+      </p:sp>
+      <p:sp>
+        <p:nvSpPr>
+          <p:cNvPr id="24" name="TextBox 23"/>
+          <p:cNvSpPr txBox="1"/>
+          <p:nvPr/>
+        </p:nvSpPr>
+        <p:spPr>
+          <a:xfrm>
+            <a:off x="6629400" y="4645152"/>
+            <a:ext cx="5120640" cy="237744"/>
+          </a:xfrm>
+          <a:prstGeom prst="rect">
+            <a:avLst/>
+          </a:prstGeom>
+          <a:noFill/>
+        </p:spPr>
+        <p:txBody>
+          <a:bodyPr wrap="square">
+            <a:spAutoFit/>
+          </a:bodyPr>
+          <a:lstStyle/>
+          <a:p>
+            <a:pPr algn="l"/>
+            <a:r>
+              <a:rPr sz="1200" b="1" i="0">
+                <a:solidFill>
+                  <a:srgbClr val="FFD166"/>
+                </a:solidFill>
+              </a:rPr>
+              <a:t>Course_Textbook:</a:t>
+            </a:r>
+          </a:p>
+        </p:txBody>
+      </p:sp>
+      <p:sp>
+        <p:nvSpPr>
+          <p:cNvPr id="25" name="TextBox 24"/>
+          <p:cNvSpPr txBox="1"/>
+          <p:nvPr/>
+        </p:nvSpPr>
+        <p:spPr>
+          <a:xfrm>
+            <a:off x="6629400" y="4882896"/>
+            <a:ext cx="5120640" cy="292608"/>
+          </a:xfrm>
+          <a:prstGeom prst="rect">
+            <a:avLst/>
+          </a:prstGeom>
+          <a:noFill/>
+        </p:spPr>
+        <p:txBody>
+          <a:bodyPr wrap="square">
+            <a:spAutoFit/>
+          </a:bodyPr>
+          <a:lstStyle/>
+          <a:p>
+            <a:pPr algn="l"/>
+            <a:r>
+              <a:rPr sz="1100" b="0" i="0">
+                <a:solidFill>
+                  <a:srgbClr val="ECEFF4"/>
+                </a:solidFill>
+              </a:rPr>
+              <a:t>CourseID  |  Textbook</a:t>
+            </a:r>
+          </a:p>
+        </p:txBody>
+      </p:sp>
+    </p:spTree>
+  </p:cSld>
+  <p:clrMapOvr>
+    <a:masterClrMapping/>
+  </p:clrMapOvr>
+</p:sld>
+</file>
+
+<file path=ppt/slides/slide11.xml><?xml version="1.0" encoding="utf-8"?>
+<p:sld xmlns:a="http://schemas.openxmlformats.org/drawingml/2006/main" xmlns:p="http://schemas.openxmlformats.org/presentationml/2006/main" xmlns:r="http://schemas.openxmlformats.org/officeDocument/2006/relationships">
+  <p:cSld>
+    <p:spTree>
+      <p:nvGrpSpPr>
+        <p:cNvPr id="1" name=""/>
+        <p:cNvGrpSpPr/>
+        <p:nvPr/>
+      </p:nvGrpSpPr>
+      <p:grpSpPr>
+        <a:xfrm>
+          <a:off x="0" y="0"/>
+          <a:ext cx="0" cy="0"/>
+          <a:chOff x="0" y="0"/>
+          <a:chExt cx="0" cy="0"/>
+        </a:xfrm>
+      </p:grpSpPr>
+      <p:sp>
+        <p:nvSpPr>
+          <p:cNvPr id="2" name="Rectangle 1"/>
+          <p:cNvSpPr/>
+          <p:nvPr/>
+        </p:nvSpPr>
+        <p:spPr>
+          <a:xfrm>
+            <a:off x="0" y="0"/>
+            <a:ext cx="12188952" cy="6858000"/>
+          </a:xfrm>
+          <a:prstGeom prst="rect">
+            <a:avLst/>
+          </a:prstGeom>
+          <a:solidFill>
+            <a:srgbClr val="0D1B2A"/>
+          </a:solidFill>
+          <a:ln>
+            <a:noFill/>
+          </a:ln>
+        </p:spPr>
+        <p:style>
+          <a:lnRef idx="1">
+            <a:schemeClr val="accent1"/>
+          </a:lnRef>
+          <a:fillRef idx="3">
+            <a:schemeClr val="accent1"/>
+          </a:fillRef>
+          <a:effectRef idx="2">
+            <a:schemeClr val="accent1"/>
+          </a:effectRef>
+          <a:fontRef idx="minor">
+            <a:schemeClr val="lt1"/>
+          </a:fontRef>
+        </p:style>
+        <p:txBody>
+          <a:bodyPr rtlCol="0" anchor="ctr"/>
+          <a:lstStyle/>
+          <a:p>
+            <a:pPr algn="ctr"/>
+            <a:endParaRPr/>
+          </a:p>
+        </p:txBody>
+      </p:sp>
+      <p:sp>
+        <p:nvSpPr>
+          <p:cNvPr id="3" name="Rectangle 2"/>
+          <p:cNvSpPr/>
+          <p:nvPr/>
+        </p:nvSpPr>
+        <p:spPr>
+          <a:xfrm>
+            <a:off x="0" y="0"/>
+            <a:ext cx="12188952" cy="109728"/>
+          </a:xfrm>
+          <a:prstGeom prst="rect">
+            <a:avLst/>
+          </a:prstGeom>
+          <a:solidFill>
+            <a:srgbClr val="268BD2"/>
+          </a:solidFill>
+          <a:ln>
+            <a:noFill/>
+          </a:ln>
+        </p:spPr>
+        <p:style>
+          <a:lnRef idx="1">
+            <a:schemeClr val="accent1"/>
+          </a:lnRef>
+          <a:fillRef idx="3">
+            <a:schemeClr val="accent1"/>
+          </a:fillRef>
+          <a:effectRef idx="2">
+            <a:schemeClr val="accent1"/>
+          </a:effectRef>
+          <a:fontRef idx="minor">
+            <a:schemeClr val="lt1"/>
+          </a:fontRef>
+        </p:style>
+        <p:txBody>
+          <a:bodyPr rtlCol="0" anchor="ctr"/>
+          <a:lstStyle/>
+          <a:p>
+            <a:pPr algn="ctr"/>
+            <a:endParaRPr/>
+          </a:p>
+        </p:txBody>
+      </p:sp>
+      <p:sp>
+        <p:nvSpPr>
+          <p:cNvPr id="4" name="Rectangle 3"/>
+          <p:cNvSpPr/>
+          <p:nvPr/>
+        </p:nvSpPr>
+        <p:spPr>
+          <a:xfrm>
+            <a:off x="0" y="6629400"/>
+            <a:ext cx="12188952" cy="228600"/>
+          </a:xfrm>
+          <a:prstGeom prst="rect">
+            <a:avLst/>
+          </a:prstGeom>
+          <a:solidFill>
+            <a:srgbClr val="1B488B"/>
+          </a:solidFill>
+          <a:ln>
+            <a:noFill/>
+          </a:ln>
+        </p:spPr>
+        <p:style>
+          <a:lnRef idx="1">
+            <a:schemeClr val="accent1"/>
+          </a:lnRef>
+          <a:fillRef idx="3">
+            <a:schemeClr val="accent1"/>
+          </a:fillRef>
+          <a:effectRef idx="2">
+            <a:schemeClr val="accent1"/>
+          </a:effectRef>
+          <a:fontRef idx="minor">
+            <a:schemeClr val="lt1"/>
+          </a:fontRef>
+        </p:style>
+        <p:txBody>
+          <a:bodyPr rtlCol="0" anchor="ctr"/>
+          <a:lstStyle/>
+          <a:p>
+            <a:pPr algn="ctr"/>
+            <a:endParaRPr/>
+          </a:p>
+        </p:txBody>
+      </p:sp>
+      <p:sp>
+        <p:nvSpPr>
+          <p:cNvPr id="5" name="TextBox 4"/>
+          <p:cNvSpPr txBox="1"/>
+          <p:nvPr/>
+        </p:nvSpPr>
+        <p:spPr>
+          <a:xfrm>
+            <a:off x="9601200" y="6601968"/>
+            <a:ext cx="2468880" cy="256032"/>
+          </a:xfrm>
+          <a:prstGeom prst="rect">
+            <a:avLst/>
+          </a:prstGeom>
+          <a:noFill/>
+        </p:spPr>
+        <p:txBody>
+          <a:bodyPr wrap="square">
+            <a:spAutoFit/>
+          </a:bodyPr>
+          <a:lstStyle/>
+          <a:p>
+            <a:pPr algn="r"/>
+            <a:r>
+              <a:rPr sz="900" b="0" i="0">
+                <a:solidFill>
+                  <a:srgbClr val="ECEFF4"/>
+                </a:solidFill>
+              </a:rPr>
+              <a:t>B. Normal Forms</a:t>
+            </a:r>
+          </a:p>
+        </p:txBody>
+      </p:sp>
+      <p:sp>
+        <p:nvSpPr>
+          <p:cNvPr id="6" name="Rectangle 5"/>
+          <p:cNvSpPr/>
+          <p:nvPr/>
+        </p:nvSpPr>
+        <p:spPr>
+          <a:xfrm>
+            <a:off x="365760" y="164592"/>
+            <a:ext cx="11457432" cy="868680"/>
+          </a:xfrm>
+          <a:prstGeom prst="rect">
+            <a:avLst/>
+          </a:prstGeom>
+          <a:solidFill>
+            <a:srgbClr val="1B488B"/>
+          </a:solidFill>
+          <a:ln>
+            <a:noFill/>
+          </a:ln>
+        </p:spPr>
+        <p:style>
+          <a:lnRef idx="1">
+            <a:schemeClr val="accent1"/>
+          </a:lnRef>
+          <a:fillRef idx="3">
+            <a:schemeClr val="accent1"/>
+          </a:fillRef>
+          <a:effectRef idx="2">
+            <a:schemeClr val="accent1"/>
+          </a:effectRef>
+          <a:fontRef idx="minor">
+            <a:schemeClr val="lt1"/>
+          </a:fontRef>
+        </p:style>
+        <p:txBody>
+          <a:bodyPr rtlCol="0" anchor="ctr"/>
+          <a:lstStyle/>
+          <a:p>
+            <a:pPr algn="ctr"/>
+            <a:endParaRPr/>
+          </a:p>
+        </p:txBody>
+      </p:sp>
+      <p:sp>
+        <p:nvSpPr>
+          <p:cNvPr id="7" name="TextBox 6"/>
+          <p:cNvSpPr txBox="1"/>
+          <p:nvPr/>
+        </p:nvSpPr>
+        <p:spPr>
+          <a:xfrm>
+            <a:off x="502920" y="182880"/>
+            <a:ext cx="11155680" cy="822960"/>
+          </a:xfrm>
+          <a:prstGeom prst="rect">
+            <a:avLst/>
+          </a:prstGeom>
+          <a:noFill/>
+        </p:spPr>
+        <p:txBody>
+          <a:bodyPr wrap="square">
+            <a:spAutoFit/>
+          </a:bodyPr>
+          <a:lstStyle/>
+          <a:p>
+            <a:pPr algn="l"/>
+            <a:r>
+              <a:rPr sz="2800" b="1" i="0">
+                <a:solidFill>
+                  <a:srgbClr val="FFFFFF"/>
+                </a:solidFill>
+              </a:rPr>
+              <a:t>Fifth Normal Form (5NF) — Eliminating Join Dependencies</a:t>
+            </a:r>
+          </a:p>
+        </p:txBody>
+      </p:sp>
+      <p:sp>
+        <p:nvSpPr>
+          <p:cNvPr id="8" name="Rectangle 7"/>
+          <p:cNvSpPr/>
+          <p:nvPr/>
+        </p:nvSpPr>
+        <p:spPr>
+          <a:xfrm>
+            <a:off x="365760" y="1207008"/>
+            <a:ext cx="11430000" cy="768096"/>
+          </a:xfrm>
+          <a:prstGeom prst="rect">
+            <a:avLst/>
+          </a:prstGeom>
+          <a:solidFill>
+            <a:srgbClr val="1B488B"/>
+          </a:solidFill>
+          <a:ln>
+            <a:noFill/>
+          </a:ln>
+        </p:spPr>
+        <p:style>
+          <a:lnRef idx="1">
+            <a:schemeClr val="accent1"/>
+          </a:lnRef>
+          <a:fillRef idx="3">
+            <a:schemeClr val="accent1"/>
+          </a:fillRef>
+          <a:effectRef idx="2">
+            <a:schemeClr val="accent1"/>
+          </a:effectRef>
+          <a:fontRef idx="minor">
+            <a:schemeClr val="lt1"/>
+          </a:fontRef>
+        </p:style>
+        <p:txBody>
+          <a:bodyPr rtlCol="0" anchor="ctr"/>
+          <a:lstStyle/>
+          <a:p>
+            <a:pPr algn="ctr"/>
+            <a:endParaRPr/>
+          </a:p>
+        </p:txBody>
+      </p:sp>
+      <p:sp>
+        <p:nvSpPr>
+          <p:cNvPr id="9" name="TextBox 8"/>
+          <p:cNvSpPr txBox="1"/>
+          <p:nvPr/>
+        </p:nvSpPr>
+        <p:spPr>
+          <a:xfrm>
+            <a:off x="502920" y="1225296"/>
+            <a:ext cx="2743200" cy="292608"/>
+          </a:xfrm>
+          <a:prstGeom prst="rect">
+            <a:avLst/>
+          </a:prstGeom>
+          <a:noFill/>
+        </p:spPr>
+        <p:txBody>
+          <a:bodyPr wrap="square">
+            <a:spAutoFit/>
+          </a:bodyPr>
+          <a:lstStyle/>
+          <a:p>
+            <a:pPr algn="l"/>
+            <a:r>
+              <a:rPr sz="1400" b="1" i="0">
+                <a:solidFill>
+                  <a:srgbClr val="FFD166"/>
+                </a:solidFill>
+              </a:rPr>
+              <a:t>Definition</a:t>
+            </a:r>
+          </a:p>
+        </p:txBody>
+      </p:sp>
+      <p:sp>
+        <p:nvSpPr>
+          <p:cNvPr id="10" name="TextBox 9"/>
+          <p:cNvSpPr txBox="1"/>
+          <p:nvPr/>
+        </p:nvSpPr>
+        <p:spPr>
+          <a:xfrm>
+            <a:off x="502920" y="1481328"/>
+            <a:ext cx="11155680" cy="365760"/>
+          </a:xfrm>
+          <a:prstGeom prst="rect">
+            <a:avLst/>
+          </a:prstGeom>
+          <a:noFill/>
+        </p:spPr>
+        <p:txBody>
+          <a:bodyPr wrap="square">
+            <a:spAutoFit/>
+          </a:bodyPr>
+          <a:lstStyle/>
+          <a:p>
+            <a:pPr algn="l"/>
+            <a:r>
+              <a:rPr sz="1300" b="0" i="0">
+                <a:solidFill>
+                  <a:srgbClr val="FFFFFF"/>
+                </a:solidFill>
+              </a:rPr>
+              <a:t>A table is in 5NF (Project-Join Normal Form — PJNF) if: (1) It is already in 4NF, AND (2) Every non-trivial join dependency is implied by the candidate keys — the table cannot be losslessly decomposed further into smaller tables.</a:t>
+            </a:r>
+          </a:p>
+        </p:txBody>
+      </p:sp>
+      <p:sp>
+        <p:nvSpPr>
+          <p:cNvPr id="11" name="TextBox 10"/>
+          <p:cNvSpPr txBox="1"/>
+          <p:nvPr/>
+        </p:nvSpPr>
+        <p:spPr>
+          <a:xfrm>
+            <a:off x="365760" y="1938528"/>
+            <a:ext cx="11430000" cy="274320"/>
+          </a:xfrm>
+          <a:prstGeom prst="rect">
+            <a:avLst/>
+          </a:prstGeom>
+          <a:noFill/>
+        </p:spPr>
+        <p:txBody>
+          <a:bodyPr wrap="square">
+            <a:spAutoFit/>
+          </a:bodyPr>
+          <a:lstStyle/>
+          <a:p>
+            <a:pPr algn="l"/>
+            <a:r>
+              <a:rPr sz="1300" b="0" i="0">
+                <a:solidFill>
+                  <a:srgbClr val="FFD166"/>
+                </a:solidFill>
+              </a:rPr>
+              <a:t>⚠  Join Dependency (JD): Table T satisfies a JD when it can be LOSSLESSLY split into 3 or more projections T1, T2, T3 … such that T = T1 ⋈ T2 ⋈ T3 ⋈ … — and this split is NOT forced by the candidate keys.</a:t>
+            </a:r>
+          </a:p>
+        </p:txBody>
+      </p:sp>
+      <p:sp>
+        <p:nvSpPr>
+          <p:cNvPr id="12" name="TextBox 11"/>
+          <p:cNvSpPr txBox="1"/>
+          <p:nvPr/>
+        </p:nvSpPr>
+        <p:spPr>
+          <a:xfrm>
+            <a:off x="365760" y="2304288"/>
+            <a:ext cx="5486400" cy="274320"/>
+          </a:xfrm>
+          <a:prstGeom prst="rect">
+            <a:avLst/>
+          </a:prstGeom>
+          <a:noFill/>
+        </p:spPr>
+        <p:txBody>
+          <a:bodyPr wrap="square">
+            <a:spAutoFit/>
+          </a:bodyPr>
+          <a:lstStyle/>
+          <a:p>
+            <a:pPr algn="l"/>
+            <a:r>
+              <a:rPr sz="1200" b="1" i="0" dirty="0">
+                <a:solidFill>
+                  <a:srgbClr val="E74C3C"/>
+                </a:solidFill>
+              </a:rPr>
+              <a:t>❌  Violation Example (Ternary Relationship):</a:t>
+            </a:r>
+          </a:p>
+        </p:txBody>
+      </p:sp>
+      <p:sp>
+        <p:nvSpPr>
+          <p:cNvPr id="13" name="Rectangle 12"/>
+          <p:cNvSpPr/>
+          <p:nvPr/>
+        </p:nvSpPr>
+        <p:spPr>
+          <a:xfrm>
+            <a:off x="365760" y="2596896"/>
+            <a:ext cx="11430000" cy="658368"/>
+          </a:xfrm>
+          <a:prstGeom prst="rect">
+            <a:avLst/>
+          </a:prstGeom>
+          <a:solidFill>
+            <a:srgbClr val="102540"/>
+          </a:solidFill>
+          <a:ln>
+            <a:noFill/>
+          </a:ln>
+        </p:spPr>
+        <p:style>
+          <a:lnRef idx="1">
+            <a:schemeClr val="accent1"/>
+          </a:lnRef>
+          <a:fillRef idx="3">
+            <a:schemeClr val="accent1"/>
+          </a:fillRef>
+          <a:effectRef idx="2">
+            <a:schemeClr val="accent1"/>
+          </a:effectRef>
+          <a:fontRef idx="minor">
+            <a:schemeClr val="lt1"/>
+          </a:fontRef>
+        </p:style>
+        <p:txBody>
+          <a:bodyPr rtlCol="0" anchor="ctr"/>
+          <a:lstStyle/>
+          <a:p>
+            <a:pPr algn="ctr"/>
+            <a:endParaRPr/>
+          </a:p>
+        </p:txBody>
+      </p:sp>
+      <p:sp>
+        <p:nvSpPr>
+          <p:cNvPr id="14" name="TextBox 13"/>
+          <p:cNvSpPr txBox="1"/>
+          <p:nvPr/>
+        </p:nvSpPr>
+        <p:spPr>
+          <a:xfrm>
+            <a:off x="502920" y="2615184"/>
+            <a:ext cx="11155680" cy="621792"/>
+          </a:xfrm>
+          <a:prstGeom prst="rect">
+            <a:avLst/>
+          </a:prstGeom>
+          <a:noFill/>
+        </p:spPr>
+        <p:txBody>
+          <a:bodyPr wrap="square">
+            <a:spAutoFit/>
+          </a:bodyPr>
+          <a:lstStyle/>
+          <a:p>
+            <a:pPr algn="l"/>
+            <a:r>
+              <a:rPr sz="1100" b="0" i="0">
+                <a:solidFill>
+                  <a:srgbClr val="ECEFF4"/>
+                </a:solidFill>
+              </a:rPr>
+              <a:t>  Supplier  |  Product    |  Project</a:t>
+            </a:r>
+          </a:p>
+          <a:p>
+            <a:pPr algn="l"/>
+            <a:r>
+              <a:rPr sz="1100" b="0" i="0">
+                <a:solidFill>
+                  <a:srgbClr val="ECEFF4"/>
+                </a:solidFill>
+              </a:rPr>
+              <a:t>  ──────────────────────────────────────────</a:t>
+            </a:r>
+          </a:p>
+          <a:p>
+            <a:pPr algn="l"/>
+            <a:r>
+              <a:rPr sz="1100" b="0" i="0">
+                <a:solidFill>
+                  <a:srgbClr val="ECEFF4"/>
+                </a:solidFill>
+              </a:rPr>
+              <a:t>  S1        |  P1         |  J1</a:t>
+            </a:r>
+          </a:p>
+          <a:p>
+            <a:pPr algn="l"/>
+            <a:r>
+              <a:rPr sz="1100" b="0" i="0">
+                <a:solidFill>
+                  <a:srgbClr val="ECEFF4"/>
+                </a:solidFill>
+              </a:rPr>
+              <a:t>  S1        |  P1         |  J2</a:t>
+            </a:r>
+          </a:p>
+          <a:p>
+            <a:pPr algn="l"/>
+            <a:r>
+              <a:rPr sz="1100" b="0" i="0">
+                <a:solidFill>
+                  <a:srgbClr val="ECEFF4"/>
+                </a:solidFill>
+              </a:rPr>
+              <a:t>  S1        |  P2         |  J1</a:t>
+            </a:r>
+          </a:p>
+          <a:p>
+            <a:pPr algn="l"/>
+            <a:r>
+              <a:rPr sz="1100" b="0" i="0">
+                <a:solidFill>
+                  <a:srgbClr val="ECEFF4"/>
+                </a:solidFill>
+              </a:rPr>
+              <a:t>  S2        |  P1         |  J1</a:t>
+            </a:r>
+          </a:p>
+        </p:txBody>
+      </p:sp>
+      <p:sp>
+        <p:nvSpPr>
+          <p:cNvPr id="15" name="TextBox 14"/>
+          <p:cNvSpPr txBox="1"/>
+          <p:nvPr/>
+        </p:nvSpPr>
+        <p:spPr>
+          <a:xfrm>
+            <a:off x="365760" y="3328416"/>
+            <a:ext cx="7772400" cy="877824"/>
+          </a:xfrm>
+          <a:prstGeom prst="rect">
+            <a:avLst/>
+          </a:prstGeom>
+          <a:noFill/>
+        </p:spPr>
+        <p:txBody>
+          <a:bodyPr wrap="square">
+            <a:spAutoFit/>
+          </a:bodyPr>
+          <a:lstStyle/>
+          <a:p>
+            <a:pPr algn="l"/>
+            <a:r>
+              <a:rPr sz="1200" b="0" dirty="0">
+                <a:solidFill>
+                  <a:srgbClr val="FFFFFF"/>
+                </a:solidFill>
+              </a:rPr>
+              <a:t>  Can be split losslessly into three binary tables:</a:t>
+            </a:r>
+          </a:p>
+          <a:p>
+            <a:pPr algn="l"/>
+            <a:r>
+              <a:rPr sz="1200" b="0" dirty="0">
+                <a:solidFill>
+                  <a:srgbClr val="FFD166"/>
+                </a:solidFill>
+              </a:rPr>
+              <a:t>  SP(Supplier,Product)  ⋈  SJ(Supplier,Project)  ⋈  PJ(Product,Project)</a:t>
+            </a:r>
+          </a:p>
+          <a:p>
+            <a:pPr algn="l"/>
+            <a:r>
+              <a:rPr sz="1200" b="0" dirty="0">
+                <a:solidFill>
+                  <a:srgbClr val="E74C3C"/>
+                </a:solidFill>
+              </a:rPr>
+              <a:t>  Storing them in one table creates redundancy → violates 5NF!</a:t>
+            </a:r>
+          </a:p>
+        </p:txBody>
+      </p:sp>
+      <p:sp>
+        <p:nvSpPr>
+          <p:cNvPr id="16" name="Rectangle 15"/>
+          <p:cNvSpPr/>
+          <p:nvPr/>
+        </p:nvSpPr>
+        <p:spPr>
+          <a:xfrm>
+            <a:off x="8275320" y="3328416"/>
+            <a:ext cx="3474720" cy="877824"/>
+          </a:xfrm>
+          <a:prstGeom prst="rect">
+            <a:avLst/>
+          </a:prstGeom>
+          <a:solidFill>
+            <a:srgbClr val="401010"/>
+          </a:solidFill>
+          <a:ln>
+            <a:noFill/>
+          </a:ln>
+        </p:spPr>
+        <p:style>
+          <a:lnRef idx="1">
+            <a:schemeClr val="accent1"/>
+          </a:lnRef>
+          <a:fillRef idx="3">
+            <a:schemeClr val="accent1"/>
+          </a:fillRef>
+          <a:effectRef idx="2">
+            <a:schemeClr val="accent1"/>
+          </a:effectRef>
+          <a:fontRef idx="minor">
+            <a:schemeClr val="lt1"/>
+          </a:fontRef>
+        </p:style>
+        <p:txBody>
+          <a:bodyPr rtlCol="0" anchor="ctr"/>
+          <a:lstStyle/>
+          <a:p>
+            <a:pPr algn="ctr"/>
+            <a:endParaRPr/>
+          </a:p>
+        </p:txBody>
+      </p:sp>
+      <p:sp>
+        <p:nvSpPr>
+          <p:cNvPr id="17" name="TextBox 16"/>
+          <p:cNvSpPr txBox="1"/>
+          <p:nvPr/>
+        </p:nvSpPr>
+        <p:spPr>
+          <a:xfrm>
+            <a:off x="8366760" y="3346704"/>
+            <a:ext cx="3291840" cy="256032"/>
+          </a:xfrm>
+          <a:prstGeom prst="rect">
+            <a:avLst/>
+          </a:prstGeom>
+          <a:noFill/>
+        </p:spPr>
+        <p:txBody>
+          <a:bodyPr wrap="square">
+            <a:spAutoFit/>
+          </a:bodyPr>
+          <a:lstStyle/>
+          <a:p>
+            <a:pPr algn="l"/>
+            <a:r>
+              <a:rPr sz="1200" b="1" i="0">
+                <a:solidFill>
+                  <a:srgbClr val="FFD166"/>
+                </a:solidFill>
+              </a:rPr>
+              <a:t>Why It Matters:</a:t>
+            </a:r>
+          </a:p>
+        </p:txBody>
+      </p:sp>
+      <p:sp>
+        <p:nvSpPr>
+          <p:cNvPr id="18" name="TextBox 17"/>
+          <p:cNvSpPr txBox="1"/>
+          <p:nvPr/>
+        </p:nvSpPr>
+        <p:spPr>
+          <a:xfrm>
+            <a:off x="8366760" y="3621024"/>
+            <a:ext cx="3291840" cy="548640"/>
+          </a:xfrm>
+          <a:prstGeom prst="rect">
+            <a:avLst/>
+          </a:prstGeom>
+          <a:noFill/>
+        </p:spPr>
+        <p:txBody>
+          <a:bodyPr wrap="square">
+            <a:spAutoFit/>
+          </a:bodyPr>
+          <a:lstStyle/>
+          <a:p>
+            <a:pPr algn="l"/>
+            <a:r>
+              <a:rPr sz="1100" b="0">
+                <a:solidFill>
+                  <a:srgbClr val="FFFFFF"/>
+                </a:solidFill>
+              </a:rPr>
+              <a:t>  ⚠  Update Anomaly</a:t>
+            </a:r>
+          </a:p>
+          <a:p>
+            <a:pPr algn="l"/>
+            <a:r>
+              <a:rPr sz="1100" b="0">
+                <a:solidFill>
+                  <a:srgbClr val="FFFFFF"/>
+                </a:solidFill>
+              </a:rPr>
+              <a:t>  ⚠  Insertion Anomaly</a:t>
+            </a:r>
+          </a:p>
+          <a:p>
+            <a:pPr algn="l"/>
+            <a:r>
+              <a:rPr sz="1100" b="0">
+                <a:solidFill>
+                  <a:srgbClr val="FFFFFF"/>
+                </a:solidFill>
+              </a:rPr>
+              <a:t>  ⚠  Deletion Anomaly</a:t>
+            </a:r>
+          </a:p>
+        </p:txBody>
+      </p:sp>
+      <p:sp>
+        <p:nvSpPr>
+          <p:cNvPr id="19" name="TextBox 18"/>
+          <p:cNvSpPr txBox="1"/>
+          <p:nvPr/>
+        </p:nvSpPr>
+        <p:spPr>
+          <a:xfrm>
+            <a:off x="365760" y="4315968"/>
+            <a:ext cx="7315200" cy="274320"/>
+          </a:xfrm>
+          <a:prstGeom prst="rect">
+            <a:avLst/>
+          </a:prstGeom>
+          <a:noFill/>
+        </p:spPr>
+        <p:txBody>
+          <a:bodyPr wrap="square">
+            <a:spAutoFit/>
+          </a:bodyPr>
+          <a:lstStyle/>
+          <a:p>
+            <a:pPr algn="l"/>
+            <a:r>
+              <a:rPr sz="1200" b="1" i="0">
+                <a:solidFill>
+                  <a:srgbClr val="2ECC71"/>
+                </a:solidFill>
+              </a:rPr>
+              <a:t>✅  Solution — Decompose into 3 binary tables:</a:t>
+            </a:r>
+          </a:p>
+        </p:txBody>
+      </p:sp>
+      <p:sp>
+        <p:nvSpPr>
+          <p:cNvPr id="20" name="Rectangle 19"/>
+          <p:cNvSpPr/>
+          <p:nvPr/>
+        </p:nvSpPr>
+        <p:spPr>
+          <a:xfrm>
+            <a:off x="365760" y="4626864"/>
+            <a:ext cx="5303520" cy="585216"/>
+          </a:xfrm>
+          <a:prstGeom prst="rect">
+            <a:avLst/>
+          </a:prstGeom>
+          <a:solidFill>
+            <a:srgbClr val="0D301A"/>
+          </a:solidFill>
+          <a:ln>
+            <a:noFill/>
+          </a:ln>
+        </p:spPr>
+        <p:style>
+          <a:lnRef idx="1">
+            <a:schemeClr val="accent1"/>
+          </a:lnRef>
+          <a:fillRef idx="3">
+            <a:schemeClr val="accent1"/>
+          </a:fillRef>
+          <a:effectRef idx="2">
+            <a:schemeClr val="accent1"/>
+          </a:effectRef>
+          <a:fontRef idx="minor">
+            <a:schemeClr val="lt1"/>
+          </a:fontRef>
+        </p:style>
+        <p:txBody>
+          <a:bodyPr rtlCol="0" anchor="ctr"/>
+          <a:lstStyle/>
+          <a:p>
+            <a:pPr algn="ctr"/>
+            <a:endParaRPr/>
+          </a:p>
+        </p:txBody>
+      </p:sp>
+      <p:sp>
+        <p:nvSpPr>
+          <p:cNvPr id="21" name="TextBox 20"/>
+          <p:cNvSpPr txBox="1"/>
+          <p:nvPr/>
+        </p:nvSpPr>
+        <p:spPr>
+          <a:xfrm>
+            <a:off x="502920" y="4645152"/>
+            <a:ext cx="5120640" cy="237744"/>
+          </a:xfrm>
+          <a:prstGeom prst="rect">
+            <a:avLst/>
+          </a:prstGeom>
+          <a:noFill/>
+        </p:spPr>
+        <p:txBody>
+          <a:bodyPr wrap="square">
+            <a:spAutoFit/>
+          </a:bodyPr>
+          <a:lstStyle/>
+          <a:p>
+            <a:pPr algn="l"/>
+            <a:r>
+              <a:rPr sz="1200" b="1" i="0">
+                <a:solidFill>
+                  <a:srgbClr val="FFD166"/>
+                </a:solidFill>
+              </a:rPr>
+              <a:t>Supplier_Product:</a:t>
+            </a:r>
+          </a:p>
+        </p:txBody>
+      </p:sp>
+      <p:sp>
+        <p:nvSpPr>
+          <p:cNvPr id="22" name="TextBox 21"/>
+          <p:cNvSpPr txBox="1"/>
+          <p:nvPr/>
+        </p:nvSpPr>
+        <p:spPr>
+          <a:xfrm>
+            <a:off x="502920" y="4882896"/>
+            <a:ext cx="5120640" cy="292608"/>
+          </a:xfrm>
+          <a:prstGeom prst="rect">
+            <a:avLst/>
+          </a:prstGeom>
+          <a:noFill/>
+        </p:spPr>
+        <p:txBody>
+          <a:bodyPr wrap="square">
+            <a:spAutoFit/>
+          </a:bodyPr>
+          <a:lstStyle/>
+          <a:p>
+            <a:pPr algn="l"/>
+            <a:r>
+              <a:rPr sz="1100" b="0" i="0">
+                <a:solidFill>
+                  <a:srgbClr val="ECEFF4"/>
+                </a:solidFill>
+              </a:rPr>
+              <a:t>Supplier  |  Product</a:t>
+            </a:r>
+          </a:p>
+        </p:txBody>
+      </p:sp>
+      <p:sp>
+        <p:nvSpPr>
+          <p:cNvPr id="23" name="Rectangle 22"/>
+          <p:cNvSpPr/>
+          <p:nvPr/>
+        </p:nvSpPr>
+        <p:spPr>
+          <a:xfrm>
+            <a:off x="6492240" y="4626864"/>
+            <a:ext cx="5303520" cy="585216"/>
+          </a:xfrm>
+          <a:prstGeom prst="rect">
+            <a:avLst/>
+          </a:prstGeom>
+          <a:solidFill>
+            <a:srgbClr val="0D301A"/>
+          </a:solidFill>
+          <a:ln>
+            <a:noFill/>
+          </a:ln>
+        </p:spPr>
+        <p:style>
+          <a:lnRef idx="1">
+            <a:schemeClr val="accent1"/>
+          </a:lnRef>
+          <a:fillRef idx="3">
+            <a:schemeClr val="accent1"/>
+          </a:fillRef>
+          <a:effectRef idx="2">
+            <a:schemeClr val="accent1"/>
+          </a:effectRef>
+          <a:fontRef idx="minor">
+            <a:schemeClr val="lt1"/>
+          </a:fontRef>
+        </p:style>
+        <p:txBody>
+          <a:bodyPr rtlCol="0" anchor="ctr"/>
+          <a:lstStyle/>
+          <a:p>
+            <a:pPr algn="ctr"/>
+            <a:endParaRPr/>
+          </a:p>
+        </p:txBody>
+      </p:sp>
+      <p:sp>
+        <p:nvSpPr>
+          <p:cNvPr id="24" name="TextBox 23"/>
+          <p:cNvSpPr txBox="1"/>
+          <p:nvPr/>
+        </p:nvSpPr>
+        <p:spPr>
+          <a:xfrm>
+            <a:off x="6629400" y="4645152"/>
+            <a:ext cx="5120640" cy="237744"/>
+          </a:xfrm>
+          <a:prstGeom prst="rect">
+            <a:avLst/>
+          </a:prstGeom>
+          <a:noFill/>
+        </p:spPr>
+        <p:txBody>
+          <a:bodyPr wrap="square">
+            <a:spAutoFit/>
+          </a:bodyPr>
+          <a:lstStyle/>
+          <a:p>
+            <a:pPr algn="l"/>
+            <a:r>
+              <a:rPr sz="1200" b="1" i="0">
+                <a:solidFill>
+                  <a:srgbClr val="FFD166"/>
+                </a:solidFill>
+              </a:rPr>
+              <a:t>Supplier_Project:</a:t>
+            </a:r>
+          </a:p>
+        </p:txBody>
+      </p:sp>
+      <p:sp>
+        <p:nvSpPr>
+          <p:cNvPr id="25" name="TextBox 24"/>
+          <p:cNvSpPr txBox="1"/>
+          <p:nvPr/>
+        </p:nvSpPr>
+        <p:spPr>
+          <a:xfrm>
+            <a:off x="6629400" y="4882896"/>
+            <a:ext cx="5120640" cy="292608"/>
+          </a:xfrm>
+          <a:prstGeom prst="rect">
+            <a:avLst/>
+          </a:prstGeom>
+          <a:noFill/>
+        </p:spPr>
+        <p:txBody>
+          <a:bodyPr wrap="square">
+            <a:spAutoFit/>
+          </a:bodyPr>
+          <a:lstStyle/>
+          <a:p>
+            <a:pPr algn="l"/>
+            <a:r>
+              <a:rPr sz="1100" b="0" i="0">
+                <a:solidFill>
+                  <a:srgbClr val="ECEFF4"/>
+                </a:solidFill>
+              </a:rPr>
+              <a:t>Supplier  |  Project</a:t>
             </a:r>
           </a:p>
         </p:txBody>

</xml_diff>